<commit_message>
Claude: add full speaker script to report slide notes
Co-Authored-By: Claude Opus 5.5 <noreply@anthropic.com>
Claude-Session: https://claude.ai/code/session_0174w6y8DLTnkTL5MuadTHAH
</commit_message>
<xml_diff>
--- a/CLAUDE/reports/World_Model_ASIC_report_2026-10-13.pptx
+++ b/CLAUDE/reports/World_Model_ASIC_report_2026-10-13.pptx
@@ -535,7 +535,13 @@
           <a:p>
             <a:r>
               <a:rPr lang="zh-TW" altLang="en-US" dirty="0"/>
-              <a:t>老師好，今天報告世界模型與 VLA 推論加速器的研究：機器人用的推論晶片，應該在哪裡和語言模型加速器做出區別。</a:t>
+              <a:t>老師好，今天由我來報告。題目是：World Model 與 VLA 的推論加速——機器人用的 ASIC，應該在哪裡和語言模型加速器做出區別。</a:t>
+            </a:r>
+          </a:p>
+          <a:p>
+            <a:r>
+              <a:rPr lang="zh-TW" altLang="en-US" dirty="0"/>
+              <a:t>這份報告整理了我們研究 repo 裡三輪的分析，以及一個六十億參數模型的深入案例。報告大約十八分鐘，最後有三個問題想請教老師。</a:t>
             </a:r>
           </a:p>
         </p:txBody>
@@ -594,7 +600,25 @@
           <a:p>
             <a:r>
               <a:rPr lang="zh-TW" altLang="en-US" dirty="0"/>
-              <a:t>老師好。今天報告的問題是：為機器人用的世界模型設計推論晶片，應該和現在的大型語言模型加速器有什麼不同。現有加速器多半是為語言模型服務設計的，假設很長的逐字生成和不斷長大的 KV cache；但機器人模型的計算形狀不一樣：計算圖固定、只有幾步到十步、每步是中等大小的矩陣。所以我們想釐清：哪些語言模型的加速技巧能搬過來，晶片又該在哪裡做出區別。</a:t>
+              <a:t>先說研究背景。這兩年機器人基礎模型發展很快，大致有三類：直接從畫面和指令輸出動作的 VLA；會預測未來畫面的影片世界模型；以及兩者合在一起、同時預測畫面和動作的世界動作模型。這些模型正在從資料中心，往機器人身上的邊緣晶片移動。</a:t>
+            </a:r>
+          </a:p>
+          <a:p>
+            <a:r>
+              <a:rPr lang="zh-TW" altLang="en-US" dirty="0"/>
+              <a:t>問題是，目前的 AI 加速器幾乎都是為語言模型服務最佳化的。語言模型的特徵是很長的自回歸 decode，一次生一個 token，而且 KV cache 會隨對話一路長大。</a:t>
+            </a:r>
+          </a:p>
+          <a:p>
+            <a:r>
+              <a:rPr lang="zh-TW" altLang="en-US" dirty="0"/>
+              <a:t>但機器人推論的形狀不一樣：計算圖是固定的，去噪只有四到十步，每一步處理的是幾十到幾百列的中等大小矩陣。所以我們不清楚語言模型那一套加速技巧有多少能搬過來，也不清楚機器人晶片真正需要哪些功能。</a:t>
+            </a:r>
+          </a:p>
+          <a:p>
+            <a:r>
+              <a:rPr lang="zh-TW" altLang="en-US" dirty="0"/>
+              <a:t>這份研究的目標，就是找出世界模型和 VLA 的 ASIC，應該在哪裡和傳統的語言模型加速器做出區別。</a:t>
             </a:r>
           </a:p>
         </p:txBody>
@@ -653,7 +677,13 @@
           <a:p>
             <a:r>
               <a:rPr lang="zh-TW" altLang="en-US" dirty="0"/>
-              <a:t>我們分析了十二個開源模型，分成五類，以 Llama 3.1 作對照。架構參數都直接讀自原始碼，計算量直接計數；再做 roofline 分析，並用 SCALE-Sim 校準的週期級模擬評估陣列利用率。研究由三個 AI 協作者分工撰寫並互相審查。</a:t>
+              <a:t>研究方法有四個部分。第一，我們從十二個開源模型的原始碼直接讀出架構參數，計算量也是在官方程式碼上直接計數，不靠論文描述。第二，在兩種硬體上做 roofline 分析：邊緣端以 NVIDIA Thor 等級為準，資料中心端以 H100 為準。第三，用 SCALE-Sim 校準過的週期級模擬器，評估不同陣列形狀的實際利用率。第四，這個 repo 由三個 AI 研究代理分工撰寫、互相審查，審查確實抓出了一些錯誤，我最後會說明。</a:t>
+            </a:r>
+          </a:p>
+          <a:p>
+            <a:r>
+              <a:rPr lang="zh-TW" altLang="en-US" dirty="0"/>
+              <a:t>【指著表格】下面這張表是分析對象，分成五類。Flow-matching 的 VLA，例如 π0 和 GR00T，特徵是前段跑一次、後段的動作專家迴圈四到十步。自回歸的 VLA，像 OpenVLA，本質上就是一小段語言模型 decode。影片世界模型，每一步要去噪幾千個 token。世界動作模型，同時去噪影片和動作。潛在空間的模型預測控制，編碼一次之後平行展開幾百條候選。最後一列是 Llama 3.1 8B，當作語言模型的對照組。</a:t>
             </a:r>
           </a:p>
         </p:txBody>
@@ -712,7 +742,25 @@
           <a:p>
             <a:r>
               <a:rPr lang="zh-TW" altLang="en-US" dirty="0"/>
-              <a:t>貫穿整份研究的觀念是：瓶頸不屬於某一類模型，而屬於哪個運算階段、跑在哪種硬體上。圖上每一點是一個模型的一個階段。同一個模型裡，不同階段的運算密度可以差十倍以上；同一個階段搬到頻寬較低的邊緣晶片，也可能從算力受限變成頻寬受限。所以設計晶片時要先把模型拆成階段。</a:t>
+              <a:t>接下來是貫穿整份研究最重要的觀念：瓶頸不是模型類別的屬性，而是「運算階段乘上硬體」的組合。</a:t>
+            </a:r>
+          </a:p>
+          <a:p>
+            <a:r>
+              <a:rPr lang="zh-TW" altLang="en-US" dirty="0"/>
+              <a:t>【指著圖】這張是 roofline 圖。橫軸是每從 DRAM 搬一個 byte 能做幾次運算，也就是算術強度；縱軸是可達到的算力。上面實線是 H100，下面虛線是 Thor。圖上每一個點，是某個模型的某一個階段。</a:t>
+            </a:r>
+          </a:p>
+          <a:p>
+            <a:r>
+              <a:rPr lang="zh-TW" altLang="en-US" dirty="0"/>
+              <a:t>可以看到三件事。第一，同一個模型的不同階段，算術強度可以差十倍以上，例如 VLA 的前段在右邊，動作專家在左邊。第二，同一個階段在 H100 上可能已經過了轉折點、是算力受限，但到頻寬只有約七分之一的 Thor 上，就落在斜線上、變成頻寬受限。第三，flow-matching 的動作專家落在接近語言模型 decode 的區域，而影片 DiT 在最右邊。</a:t>
+            </a:r>
+          </a:p>
+          <a:p>
+            <a:r>
+              <a:rPr lang="zh-TW" altLang="en-US" dirty="0"/>
+              <a:t>所以設計晶片之前，要先把模型拆成階段，各自算出形狀和算術強度，再對照硬體，而不是先問這是哪一類模型。</a:t>
             </a:r>
           </a:p>
         </p:txBody>
@@ -771,7 +819,25 @@
           <a:p>
             <a:r>
               <a:rPr lang="zh-TW" altLang="en-US" dirty="0"/>
-              <a:t>第一類是直接輸出動作的 VLA。前段的視覺語言模型只跑一次，後段的小型動作專家要反覆修正幾步到十步。以 π0 為例，動作專家只佔百分之九的計算量，卻佔 Thor 上一半以上的延遲，因為每一步都要重讀它的權重，但每次只算約五十列。圖中可以看到，權重從外部串流時延遲隨步數線性上升；權重放在片上時幾乎是平的。這和語言模型逐字生成很像，差別在於被重讀的網路小到有機會放進晶片，而且每次算的是矩陣而不是向量。</a:t>
+              <a:t>先看第一類，flow-matching 的 VLA。它的推論分兩段：前段的視覺語言模型把畫面和指令處理一次；後段是一個小型的動作專家，從雜訊出發做常微分方程積分，π0 積十步，GR00T 積四步。</a:t>
+            </a:r>
+          </a:p>
+          <a:p>
+            <a:r>
+              <a:rPr lang="zh-TW" altLang="en-US" dirty="0"/>
+              <a:t>以 π0 在 Thor 上為例，動作專家只佔百分之九的計算量，卻佔了百分之五十六的延遲。原因是每一步都要重新讀一次專家的權重，但每次只服務五十一列的矩陣，每個 byte 只做大約六十次運算，所以是頻寬受限。</a:t>
+            </a:r>
+          </a:p>
+          <a:p>
+            <a:r>
+              <a:rPr lang="zh-TW" altLang="en-US" dirty="0"/>
+              <a:t>【指著圖】這張圖橫軸是積分步數，縱軸是一段動作的延遲。藍線是權重每步從 DRAM 重讀，延遲隨步數線性上升；橘線是把專家權重放在片上，幾乎是平的。專家權重在 FP8 下只有 97 到 415 MB，是片上 SRAM 有機會裝得下的量級；語言模型的十幾 GB 就不可能。</a:t>
+            </a:r>
+          </a:p>
+          <a:p>
+            <a:r>
+              <a:rPr lang="zh-TW" altLang="en-US" dirty="0"/>
+              <a:t>最後要強調：這不是矩陣乘向量。每一步是四十到五十一列的矩陣，和語言模型 decode 一次一列有本質差別，這會影響後面陣列形狀的選擇。</a:t>
             </a:r>
           </a:p>
         </p:txBody>
@@ -830,7 +896,25 @@
           <a:p>
             <a:r>
               <a:rPr lang="zh-TW" altLang="en-US" dirty="0"/>
-              <a:t>需要保存的中間狀態也和語言模型完全不同。VLA 只有零點七到十幾 MB，大小由相機數和 token 數決定，每次重新規劃就丟掉；語言模型則隨上下文和批次一路長到十幾 GB。只有逐段生成的影片世界模型需要跨段保存 GB 級的滑動視窗。所以這類晶片不需要分頁式的 KV 管理，所有狀態大小在編譯時就已知。</a:t>
+              <a:t>第二個差異在需要保存的狀態，也就是 KV cache 或中間特徵。</a:t>
+            </a:r>
+          </a:p>
+          <a:p>
+            <a:r>
+              <a:rPr lang="zh-TW" altLang="en-US" dirty="0"/>
+              <a:t>【指著圖】這張圖橫軸是對數尺度的大小。灰色是語言模型，藍色是 VLA，橘色是影片世界模型，綠色是世界動作模型。</a:t>
+            </a:r>
+          </a:p>
+          <a:p>
+            <a:r>
+              <a:rPr lang="zh-TW" altLang="en-US" dirty="0"/>
+              <a:t>VLA 的狀態只有零點七到十八 MB，大小由相機數和每張圖的 token 數決定，每次重新規劃就整個丟掉。語言模型則隨上下文和批次長大，八千 token 約 1 GB，十二萬八千 token 就到 17 GB。只有逐段自回歸生成的影片模型，像 Matrix-Game 2.0 和 DreamZero，需要跨段保存 GB 級的滑動視窗。</a:t>
+            </a:r>
+          </a:p>
+          <a:p>
+            <a:r>
+              <a:rPr lang="zh-TW" altLang="en-US" dirty="0"/>
+              <a:t>所以這類晶片不需要 PagedAttention 那種分頁式的 KV 管理。所有狀態的大小在編譯時就能算出來，用靜態配置的緩衝區就夠了。</a:t>
             </a:r>
           </a:p>
         </p:txBody>
@@ -889,7 +973,25 @@
           <a:p>
             <a:r>
               <a:rPr lang="zh-TW" altLang="en-US" dirty="0"/>
-              <a:t>第三類是在潛在空間做規劃的模型。一次決策的成本約等於編碼加上搜尋輪數、候選數、預測步數和每次轉移成本的乘積。表中兩個模型都叫潛在世界模型，但一個的狀態是緊湊向量、轉移是小型 MLP，另一個是每幀 256 個 token 的 Transformer，每次轉移成本差了三到五個數量級。所以狀態表示的選擇，比候選數或步數更重要，是晶片規格的第一個參數。另外，讓動作模型一次多產生候選幾乎不增加時間，因為多出的候選搭在原本就要做的權重讀取上。</a:t>
+              <a:t>第三類是在潛在空間做規劃的模型，用來做模型預測控制。一次決策的成本，大約是編碼成本，加上搜尋輪數 I、乘候選數 K、乘預測步數 H、再乘每次轉移的成本。</a:t>
+            </a:r>
+          </a:p>
+          <a:p>
+            <a:r>
+              <a:rPr lang="zh-TW" altLang="en-US" dirty="0"/>
+              <a:t>【指著表格】我們拿兩個真實模型代進去。TD-MPC2 的狀態是一個緊湊向量，轉移模型是小型 MLP，規劃器是 MPPI，六輪、五百一十二條候選、三步。V-JEPA 2-AC 的狀態是每幀 256 個 token、每個 1024 維，轉移模型是 Transformer，規劃器是 CEM，十輪、四百條候選、兩步。兩者都叫潛在世界模型，但每次轉移的成本差了 2,400 到 90,000 倍。</a:t>
+            </a:r>
+          </a:p>
+          <a:p>
+            <a:r>
+              <a:rPr lang="zh-TW" altLang="en-US" dirty="0"/>
+              <a:t>所以我們的結論是：狀態用向量還是 token 集合來表示，是 ASIC 規格的第一個參數，比候選數、步數都重要。這類模型也是唯一能用平行候選把硬體填滿的機器人工作負載。</a:t>
+            </a:r>
+          </a:p>
+          <a:p>
+            <a:r>
+              <a:rPr lang="zh-TW" altLang="en-US" dirty="0"/>
+              <a:t>另一個發現是，「policy 提候選、世界模型評分」這種架構在硬體上幾乎是免費的：在 Thor 上讓 π0 一次產生十六段候選動作，只比一段多百分之二十五的時間，因為多出來的候選搭在原本就要做的權重讀取上。</a:t>
             </a:r>
           </a:p>
         </p:txBody>
@@ -948,7 +1050,19 @@
           <a:p>
             <a:r>
               <a:rPr lang="zh-TW" altLang="en-US" dirty="0"/>
-              <a:t>我們逐項量化了約六十項 2026 年以前的語言模型加速技巧。只有低精度權重對所有類別都有效。分頁式記憶體、動態批次、投機解碼這些招牌技巧，都建立在狀態會長大、有很多使用者可以合併的前提上，機器人兩者都沒有。影片模型真正有效的則是擴散模型才有的槓桿：減少去噪步數，以及在步與步之間重用計算。</a:t>
+              <a:t>接著我們問：語言模型的加速技巧到底能搬多少？我們把 2026 年以前大約六十項技巧，硬體和軟體都有，逐項量化對每一類模型的效果。</a:t>
+            </a:r>
+          </a:p>
+          <a:p>
+            <a:r>
+              <a:rPr lang="zh-TW" altLang="en-US" dirty="0"/>
+              <a:t>【指著熱圖】這張熱圖每一列是一項技巧，每一行是一個模型，顏色越深代表在 Thor 上的加速越大，灰色代表不適用。</a:t>
+            </a:r>
+          </a:p>
+          <a:p>
+            <a:r>
+              <a:rPr lang="zh-TW" altLang="en-US" dirty="0"/>
+              <a:t>結論可以歸納成四點。第一，低精度，也就是 FP8 和 FP4，對每一類都有效，是唯一的通用解。第二，語言模型 serving 的招牌技巧，像分頁式 KV、continuous batching、投機解碼，對 VLA 幾乎沒有效果，因為它們都假設狀態會長大、有很多使用者可以合併，機器人兩者都沒有。第三，減少權重頻寬的技巧對 VLA 有效，但對影片世界模型無效，因為後者是算力受限。第四，影片世界模型最有效的是擴散模型特有的槓桿：步數蒸餾，以及跨去噪步重用特徵，圖上顏色最深的幾格就是。</a:t>
             </a:r>
           </a:p>
         </p:txBody>
@@ -1007,7 +1121,25 @@
           <a:p>
             <a:r>
               <a:rPr lang="zh-TW" altLang="en-US" dirty="0"/>
-              <a:t>陣列層級的模擬支持這個判斷。同樣的乘加單元數，如果用一個 128 乘 128 的權重固定陣列，VLA 動作迴圈只有一成左右的利用率；切成 16 個 32 乘 32 的小陣列、讓每個矩陣自選資料流，可以提高到六到八成，而大矩陣的工作負載在小陣列上仍有九成以上。語言模型 decode 在任何陣列上都很低，這也解釋了它們為什麼轉向向量引擎。另外，權重放片上只有搭配小陣列才真正有效。</a:t>
+              <a:t>前面都在談頻寬，這一頁補上另一半：算力實際用到多少。我們用 SCALE-Sim 對 systolic array 做週期級模擬，代入每個模型真實的矩陣形狀。</a:t>
+            </a:r>
+          </a:p>
+          <a:p>
+            <a:r>
+              <a:rPr lang="zh-TW" altLang="en-US" dirty="0"/>
+              <a:t>固定一萬六千三百八十四個乘加單元，比較兩種切法：一個 TPU 式的 128 乘 128 weight-stationary 大陣列，和十六個 32 乘 32 的小陣列，並讓每個矩陣自行選擇資料流。</a:t>
+            </a:r>
+          </a:p>
+          <a:p>
+            <a:r>
+              <a:rPr lang="zh-TW" altLang="en-US" dirty="0"/>
+              <a:t>【指著熱圖】每一列是一個工作負載，左邊一組是 128 乘 128，右邊一組是 32 乘 32。VLA 的動作迴圈只有四十一到五十一列，在大陣列上只有百分之九到十二的利用率，換成小陣列提高到百分之五十九到七十七。影片 DiT、潛在規劃和 VLM 前段這些大矩陣，在小陣列上仍有百分之八十八到九十八，所以小陣列並不犧牲大矩陣。最下面兩列是語言模型 decode，在任何 systolic array 上都只有零到百分之八，這也解釋了為什麼語言模型加速器要轉向 GEMV 引擎或記憶體內運算。</a:t>
+            </a:r>
+          </a:p>
+          <a:p>
+            <a:r>
+              <a:rPr lang="zh-TW" altLang="en-US" dirty="0"/>
+              <a:t>最後一點：專家權重放片上，只有搭配小陣列才有效。在 Thor 等級晶片上，π0 一段動作從 38.0 毫秒降到 22.9 毫秒；如果仍用大陣列，瓶頸只是換成利用率。</a:t>
             </a:r>
           </a:p>
         </p:txBody>
@@ -1066,7 +1198,25 @@
           <a:p>
             <a:r>
               <a:rPr lang="zh-TW" altLang="en-US" dirty="0"/>
-              <a:t>為了驗證這些觀念，我們解剖了 Flex-π。它用 50 億參數的影片模型當主幹，加上 10 億參數的動作網路。每次推論先把當下觀測送進主幹一次，存下每層的注意力資料，這是 prefill；再對一整段動作做四步去噪。我們從原始碼算出的計算量和官方實測吻合。關鍵發現是：在邊緣硬體上，成本主體不是後段的去噪，而是每次推論都要重做的前段；語言模型可以把前段攤提掉，這裡不行。</a:t>
+              <a:t>為了驗證前面的觀念，我們挑了一個新模型做深入解剖：Flex-π，六十億參數的世界動作模型。它用 Wan 2.2 的五十億參數影片模型當主幹，再加一個十億參數的動作專家，同時去噪四種串流：未來 RGB、點雲、DINOv3 語意特徵和動作。</a:t>
+            </a:r>
+          </a:p>
+          <a:p>
+            <a:r>
+              <a:rPr lang="zh-TW" altLang="en-US" dirty="0"/>
+              <a:t>它的推論分兩段。Prefill：把當下觀測編成三百八十七個錨點 token，通過主幹一次，存下每層的 K 和 V。Decode：做四步 Euler 積分，只出動作時每步處理三十二個 token，全部一起生成時是八百零六個。</a:t>
+            </a:r>
+          </a:p>
+          <a:p>
+            <a:r>
+              <a:rPr lang="zh-TW" altLang="en-US" dirty="0"/>
+              <a:t>【指著左圖】左圖是計算量的去向，主要都是線性層，attention 分數只佔百分之二到五。【指著右圖】右圖是各模式的理想延遲和官方 RTX 5090 實測的比較，全部生成的模式吻合到百分之八十五到九十三，代表我們的計數可信。</a:t>
+            </a:r>
+          </a:p>
+          <a:p>
+            <a:r>
+              <a:rPr lang="zh-TW" altLang="en-US" dirty="0"/>
+              <a:t>最重要的是最後一點：在邊緣硬體上，只出動作的延遲主體不是 decode，而是每次推論都要重做的 prefill。語言模型的 prefill 可以被幾百步 decode 攤提，這裡不行。</a:t>
             </a:r>
           </a:p>
         </p:txBody>
@@ -1125,7 +1275,19 @@
           <a:p>
             <a:r>
               <a:rPr lang="zh-TW" altLang="en-US" dirty="0"/>
-              <a:t>我們也從原始碼找到幾處可以直接刪掉、結果完全不變的計算：只輸出動作時，主幹最上面七層算出來沒有人用；文字指令的 K/V 每步都重算，其實整個任務都不變。存下的錨點 K/V 不是語言模型意義上的快取，跨推論不能重用，只在同一次推論的幾步之間有用。表中是 Thor 等級晶片上的估算：語言模型式的設計只能降到 55.6 毫秒，加入小陣列、刪除冗餘、專家常駐片上後可降到約 19.6 毫秒。總計含編碼器約 4.8 毫秒，都是理想下限。</a:t>
+              <a:t>從官方原始碼裡，我們還找到幾處結果完全等價、可以直接刪掉的計算。第一，Flex-π 採用分層連接設計，動作只在中間十六層讀取視覺資訊；但只出動作時，prefill 仍跑完三十層，最上面七層算出來沒有人用，約佔 prefill 的百分之二十六。第二，文字指令的 cross-attention K、V 每一步都重算，其實整個任務期間都不變。第三，存下來的錨點 K/V 只有 143 MB，它不是跨推論的快取，下一次推論看到新畫面就要重建；它的價值只在同一次推論的四步之間。</a:t>
+            </a:r>
+          </a:p>
+          <a:p>
+            <a:r>
+              <a:rPr lang="zh-TW" altLang="en-US" dirty="0"/>
+              <a:t>【指著表格】這張表是 Thor 等級晶片上，只出動作模式的估算。BF16 理想值是 72 毫秒；用語言模型式的設計，FP8 加單一大陣列，只能降到 55.6；換成小陣列降到 39.3；再刪除死碼、提出不變量，降到 32.3；最後讓動作專家常駐片上，降到 19.6 毫秒。</a:t>
+            </a:r>
+          </a:p>
+          <a:p>
+            <a:r>
+              <a:rPr lang="zh-TW" altLang="en-US" dirty="0"/>
+              <a:t>做完這些以後，剩下的瓶頸幾乎只有每次推論都要串流一次五十億參數的主幹。表中總計含編碼器約 4.8 毫秒，都是理想下限。</a:t>
             </a:r>
           </a:p>
         </p:txBody>
@@ -1184,7 +1346,13 @@
           <a:p>
             <a:r>
               <a:rPr lang="zh-TW" altLang="en-US" dirty="0"/>
-              <a:t>綜合以上，我們建議的晶片和語言模型加速器有五個區別：用多個小陣列取代單一大陣列；權重依重用率分兩路，反覆讀的小網路放片上、只讀一次的大主幹用低精度串流，外部記憶體以頻寬為優先；狀態靜態配置；編譯器把每種推論模式編成固定排程，保證最壞延遲，這對閉迴路控制比平均吞吐量更重要；以及三維卷積前端。下表是規格上必須先決定的三個取捨。</a:t>
+              <a:t>綜合以上，我們建議的晶片和語言模型加速器有五個區別。運算：多個 32 乘 32 小陣列，支援 output-stationary 和 weight-stationary 切換，不做 GEMV 引擎或記憶體內運算。記憶體：兩級權重，反覆讀的專家放片上，只讀一次的主幹用 FP8 或 FP4 串流；DRAM 規格以頻寬為優先，而不是容量。狀態：靜態配置的緩衝區，大小在編譯時已知。編譯器：每種推論模式一張靜態排程，刪除冗餘計算並保證最壞延遲，這對閉迴路控制比平均吞吐量更重要。前端：支援三維卷積的 VAE，注意力只需要一個能處理結構化遮罩的小單元。</a:t>
+            </a:r>
+          </a:p>
+          <a:p>
+            <a:r>
+              <a:rPr lang="zh-TW" altLang="en-US" dirty="0"/>
+              <a:t>【指著表格】規格上有三個需要先決定的取捨。第一，要不要支援自回歸的影片世界模型：支援就要預留 GB 級的 KV 頻寬，不支援就完全不需要 KV 記憶體。第二，動作專家要放片上，需要 0.4 GB 以上的 SRAM；還是用串流加多候選批次來分攤讀取，不增加面積。第三，主幹精度：FP8 在 Thor 等級頻寬下仍是頻寬受限，要到 FP4 才能讓 prefill 轉成算力受限。</a:t>
             </a:r>
           </a:p>
         </p:txBody>
@@ -1243,7 +1411,13 @@
           <a:p>
             <a:r>
               <a:rPr lang="zh-TW" altLang="en-US" dirty="0"/>
-              <a:t>這些結論都來自原始碼計數、理論估算和模擬，不是晶片實測，也還沒實際執行 Flex-π 的權重。互審過程中我們撤回了一項加速宣稱，也修正了陣列模型的排程假設；也接受了提醒：矩陣運算加速之後，正規化、排序這類非矩陣運算可能變成新瓶頸。下一步是在 GPU 上實測多候選是否真的幾乎不增加時間，以及刪除冗餘計算的效益；若前者不成立，我們會撤回動作網路受頻寬限制的結論。</a:t>
+              <a:t>必須說明幾個限制。所有延遲都是理想 roofline 或週期模擬的下限，沒有 RTL，也沒有晶片實測。我們沒有實際執行 Flex-π 的權重，非矩陣運算和多核心之間的通訊也還沒有建模。互審過程中有一項說法被撤回：我們曾宣稱 TD-MPC2 的 Q 值頭「先抽樣再計算」可以加速，重做有鑑別力的測試後，等價性成立，但在 CPU 上沒有變快，所以撤回了加速的說法。</a:t>
+            </a:r>
+          </a:p>
+          <a:p>
+            <a:r>
+              <a:rPr lang="zh-TW" altLang="en-US" dirty="0"/>
+              <a:t>下一步有三件事。第一，在 GPU 上實測 π0 一次產生多段候選的延遲；如果十六段候選超過一段的兩倍，我們就撤回「動作專家受頻寬限制」的結論。第二，在 GPU 上量測 Flex-π 刪除死碼和提出文字 K/V 的實際效益。第三，在模擬器中加入非矩陣運算和核心間通訊，評估完整的控制週期預算。</a:t>
             </a:r>
           </a:p>
         </p:txBody>
@@ -1302,7 +1476,19 @@
           <a:p>
             <a:r>
               <a:rPr lang="zh-TW" altLang="en-US" dirty="0"/>
-              <a:t>總結一句話：機器人世界模型的晶片，差異化方向不是更大，而是更貼合它固定、短而中等大小的計算形狀。最後想請教老師三個問題：多個小陣列帶來的互連與控制成本，會吃掉多少利用率上的好處？把小網路權重放進晶片需要相當大的 SRAM，這值得嗎，還是應該優先用多候選來分攤讀取？若要往硬體原型推進，應該先驗證哪一個單元？報告到這裡，謝謝老師。</a:t>
+              <a:t>總結一句話：機器人世界模型的晶片，差異化的方向不是更大，而是更貼合它固定、短而中等大小的計算形狀。</a:t>
+            </a:r>
+          </a:p>
+          <a:p>
+            <a:r>
+              <a:rPr lang="zh-TW" altLang="en-US" dirty="0"/>
+              <a:t>最後想請教老師三個問題。第一，用多個小陣列取代單一大陣列，互連和控制的面積與功耗代價，大概會吃掉多少利用率上的好處？第二，專家權重放片上需要 0.4 GB 以上的 SRAM，以目前的製程和封裝，老師覺得值得嗎，還是應該優先做串流加多候選批次？第三，如果要往 RTL 或 FPGA 原型推進，應該先驗證哪一個單元，最能證明這個方向成立？</a:t>
+            </a:r>
+          </a:p>
+          <a:p>
+            <a:r>
+              <a:rPr lang="zh-TW" altLang="en-US" dirty="0"/>
+              <a:t>報告到這裡，謝謝老師。</a:t>
             </a:r>
           </a:p>
         </p:txBody>

</xml_diff>